<commit_message>
Update slide with real app screenshots
</commit_message>
<xml_diff>
--- a/SkyCompare_Slide.pptx
+++ b/SkyCompare_Slide.pptx
@@ -3225,8 +3225,8 @@
         </p:nvSpPr>
         <p:spPr>
           <a:xfrm>
-            <a:off x="365760" y="164592"/>
-            <a:ext cx="4572000" cy="914400"/>
+            <a:off x="320040" y="146304"/>
+            <a:ext cx="4297680" cy="914400"/>
           </a:xfrm>
           <a:prstGeom prst="rect">
             <a:avLst/>
@@ -3241,7 +3241,7 @@
           <a:p>
             <a:pPr algn="l"/>
             <a:r>
-              <a:rPr sz="5200" b="1" i="0">
+              <a:rPr sz="5000" b="1" i="0">
                 <a:solidFill>
                   <a:srgbClr val="C0392B"/>
                 </a:solidFill>
@@ -3259,8 +3259,8 @@
         </p:nvSpPr>
         <p:spPr>
           <a:xfrm>
-            <a:off x="365760" y="1097280"/>
-            <a:ext cx="4572000" cy="365760"/>
+            <a:off x="320040" y="1078992"/>
+            <a:ext cx="4297680" cy="365760"/>
           </a:xfrm>
           <a:prstGeom prst="rect">
             <a:avLst/>
@@ -3275,7 +3275,7 @@
           <a:p>
             <a:pPr algn="l"/>
             <a:r>
-              <a:rPr sz="1500" b="0" i="1">
+              <a:rPr sz="1400" b="0" i="1">
                 <a:solidFill>
                   <a:srgbClr val="AAAAAA"/>
                 </a:solidFill>
@@ -3293,8 +3293,8 @@
         </p:nvSpPr>
         <p:spPr>
           <a:xfrm>
-            <a:off x="365760" y="1600200"/>
-            <a:ext cx="4572000" cy="320040"/>
+            <a:off x="320040" y="1572768"/>
+            <a:ext cx="4297680" cy="292608"/>
           </a:xfrm>
           <a:prstGeom prst="rect">
             <a:avLst/>
@@ -3327,8 +3327,8 @@
         </p:nvSpPr>
         <p:spPr>
           <a:xfrm>
-            <a:off x="365760" y="1874519"/>
-            <a:ext cx="4572000" cy="228600"/>
+            <a:off x="320040" y="1828800"/>
+            <a:ext cx="4297680" cy="228600"/>
           </a:xfrm>
           <a:prstGeom prst="rect">
             <a:avLst/>
@@ -3361,8 +3361,8 @@
         </p:nvSpPr>
         <p:spPr>
           <a:xfrm>
-            <a:off x="365760" y="2212848"/>
-            <a:ext cx="4206240" cy="27432"/>
+            <a:off x="320040" y="2176272"/>
+            <a:ext cx="4023360" cy="27432"/>
           </a:xfrm>
           <a:prstGeom prst="rect">
             <a:avLst/>
@@ -3404,8 +3404,8 @@
         </p:nvSpPr>
         <p:spPr>
           <a:xfrm>
-            <a:off x="365760" y="2359152"/>
-            <a:ext cx="4297680" cy="3200400"/>
+            <a:off x="320040" y="2304288"/>
+            <a:ext cx="4160520" cy="3657600"/>
           </a:xfrm>
           <a:prstGeom prst="rect">
             <a:avLst/>
@@ -3420,7 +3420,7 @@
           <a:p>
             <a:pPr>
               <a:spcBef>
-                <a:spcPts val="500"/>
+                <a:spcPts val="600"/>
               </a:spcBef>
             </a:pPr>
             <a:r>
@@ -3443,7 +3443,7 @@
           <a:p>
             <a:pPr>
               <a:spcBef>
-                <a:spcPts val="500"/>
+                <a:spcPts val="600"/>
               </a:spcBef>
             </a:pPr>
             <a:r>
@@ -3466,7 +3466,7 @@
           <a:p>
             <a:pPr>
               <a:spcBef>
-                <a:spcPts val="500"/>
+                <a:spcPts val="600"/>
               </a:spcBef>
             </a:pPr>
             <a:r>
@@ -3483,13 +3483,13 @@
                   <a:srgbClr val="F0F0F0"/>
                 </a:solidFill>
               </a:rPr>
-              <a:t>Smart airport autocomplete — 80+ US airports</a:t>
+              <a:t>Airport autocomplete — 80+ US airports</a:t>
             </a:r>
           </a:p>
           <a:p>
             <a:pPr>
               <a:spcBef>
-                <a:spcPts val="500"/>
+                <a:spcPts val="600"/>
               </a:spcBef>
             </a:pPr>
             <a:r>
@@ -3506,13 +3506,13 @@
                   <a:srgbClr val="F0F0F0"/>
                 </a:solidFill>
               </a:rPr>
-              <a:t>3-priority ranking system drives the SkyScore</a:t>
+              <a:t>3-priority ranking system powers the SkyScore</a:t>
             </a:r>
           </a:p>
           <a:p>
             <a:pPr>
               <a:spcBef>
-                <a:spcPts val="500"/>
+                <a:spcPts val="600"/>
               </a:spcBef>
             </a:pPr>
             <a:r>
@@ -3529,13 +3529,13 @@
                   <a:srgbClr val="F0F0F0"/>
                 </a:solidFill>
               </a:rPr>
-              <a:t>Direct booking links pre-filled with your route &amp; date</a:t>
+              <a:t>Direct booking links pre-filled with route &amp; date</a:t>
             </a:r>
           </a:p>
           <a:p>
             <a:pPr>
               <a:spcBef>
-                <a:spcPts val="500"/>
+                <a:spcPts val="600"/>
               </a:spcBef>
             </a:pPr>
             <a:r>
@@ -3565,324 +3565,8 @@
         </p:nvSpPr>
         <p:spPr>
           <a:xfrm>
-            <a:off x="5074920" y="320040"/>
-            <a:ext cx="3246120" cy="3200400"/>
-          </a:xfrm>
-          <a:prstGeom prst="rect">
-            <a:avLst/>
-          </a:prstGeom>
-          <a:solidFill>
-            <a:srgbClr val="1E1E1E"/>
-          </a:solidFill>
-          <a:ln>
-            <a:solidFill>
-              <a:srgbClr val="333333"/>
-            </a:solidFill>
-          </a:ln>
-        </p:spPr>
-        <p:style>
-          <a:lnRef idx="1">
-            <a:schemeClr val="accent1"/>
-          </a:lnRef>
-          <a:fillRef idx="3">
-            <a:schemeClr val="accent1"/>
-          </a:fillRef>
-          <a:effectRef idx="2">
-            <a:schemeClr val="accent1"/>
-          </a:effectRef>
-          <a:fontRef idx="minor">
-            <a:schemeClr val="lt1"/>
-          </a:fontRef>
-        </p:style>
-        <p:txBody>
-          <a:bodyPr rtlCol="0" anchor="ctr"/>
-          <a:lstStyle/>
-          <a:p>
-            <a:pPr algn="ctr"/>
-          </a:p>
-        </p:txBody>
-      </p:sp>
-      <p:sp>
-        <p:nvSpPr>
-          <p:cNvPr id="12" name="TextBox 11"/>
-          <p:cNvSpPr txBox="1"/>
-          <p:nvPr/>
-        </p:nvSpPr>
-        <p:spPr>
-          <a:xfrm>
-            <a:off x="5212080" y="429768"/>
-            <a:ext cx="2926080" cy="228600"/>
-          </a:xfrm>
-          <a:prstGeom prst="rect">
-            <a:avLst/>
-          </a:prstGeom>
-          <a:noFill/>
-        </p:spPr>
-        <p:txBody>
-          <a:bodyPr wrap="none">
-            <a:spAutoFit/>
-          </a:bodyPr>
-          <a:lstStyle/>
-          <a:p>
-            <a:pPr algn="l"/>
-            <a:r>
-              <a:rPr sz="800" b="1" i="0">
-                <a:solidFill>
-                  <a:srgbClr val="C0392B"/>
-                </a:solidFill>
-              </a:rPr>
-              <a:t>FLIGHT SEARCH</a:t>
-            </a:r>
-          </a:p>
-        </p:txBody>
-      </p:sp>
-      <p:sp>
-        <p:nvSpPr>
-          <p:cNvPr id="13" name="TextBox 12"/>
-          <p:cNvSpPr txBox="1"/>
-          <p:nvPr/>
-        </p:nvSpPr>
-        <p:spPr>
-          <a:xfrm>
-            <a:off x="5212080" y="731520"/>
-            <a:ext cx="914400" cy="201168"/>
-          </a:xfrm>
-          <a:prstGeom prst="rect">
-            <a:avLst/>
-          </a:prstGeom>
-          <a:noFill/>
-        </p:spPr>
-        <p:txBody>
-          <a:bodyPr wrap="none">
-            <a:spAutoFit/>
-          </a:bodyPr>
-          <a:lstStyle/>
-          <a:p>
-            <a:pPr algn="l"/>
-            <a:r>
-              <a:rPr sz="800" b="0" i="0">
-                <a:solidFill>
-                  <a:srgbClr val="AAAAAA"/>
-                </a:solidFill>
-              </a:rPr>
-              <a:t>From</a:t>
-            </a:r>
-          </a:p>
-        </p:txBody>
-      </p:sp>
-      <p:sp>
-        <p:nvSpPr>
-          <p:cNvPr id="14" name="Rectangle 13"/>
-          <p:cNvSpPr/>
-          <p:nvPr/>
-        </p:nvSpPr>
-        <p:spPr>
-          <a:xfrm>
-            <a:off x="5212080" y="932688"/>
-            <a:ext cx="2971800" cy="274320"/>
-          </a:xfrm>
-          <a:prstGeom prst="rect">
-            <a:avLst/>
-          </a:prstGeom>
-          <a:solidFill>
-            <a:srgbClr val="2A2A2A"/>
-          </a:solidFill>
-          <a:ln>
-            <a:solidFill>
-              <a:srgbClr val="333333"/>
-            </a:solidFill>
-          </a:ln>
-        </p:spPr>
-        <p:style>
-          <a:lnRef idx="1">
-            <a:schemeClr val="accent1"/>
-          </a:lnRef>
-          <a:fillRef idx="3">
-            <a:schemeClr val="accent1"/>
-          </a:fillRef>
-          <a:effectRef idx="2">
-            <a:schemeClr val="accent1"/>
-          </a:effectRef>
-          <a:fontRef idx="minor">
-            <a:schemeClr val="lt1"/>
-          </a:fontRef>
-        </p:style>
-        <p:txBody>
-          <a:bodyPr rtlCol="0" anchor="ctr"/>
-          <a:lstStyle/>
-          <a:p>
-            <a:pPr algn="ctr"/>
-          </a:p>
-        </p:txBody>
-      </p:sp>
-      <p:sp>
-        <p:nvSpPr>
-          <p:cNvPr id="15" name="TextBox 14"/>
-          <p:cNvSpPr txBox="1"/>
-          <p:nvPr/>
-        </p:nvSpPr>
-        <p:spPr>
-          <a:xfrm>
-            <a:off x="5212080" y="1280160"/>
-            <a:ext cx="914400" cy="201168"/>
-          </a:xfrm>
-          <a:prstGeom prst="rect">
-            <a:avLst/>
-          </a:prstGeom>
-          <a:noFill/>
-        </p:spPr>
-        <p:txBody>
-          <a:bodyPr wrap="none">
-            <a:spAutoFit/>
-          </a:bodyPr>
-          <a:lstStyle/>
-          <a:p>
-            <a:pPr algn="l"/>
-            <a:r>
-              <a:rPr sz="800" b="0" i="0">
-                <a:solidFill>
-                  <a:srgbClr val="AAAAAA"/>
-                </a:solidFill>
-              </a:rPr>
-              <a:t>To</a:t>
-            </a:r>
-          </a:p>
-        </p:txBody>
-      </p:sp>
-      <p:sp>
-        <p:nvSpPr>
-          <p:cNvPr id="16" name="Rectangle 15"/>
-          <p:cNvSpPr/>
-          <p:nvPr/>
-        </p:nvSpPr>
-        <p:spPr>
-          <a:xfrm>
-            <a:off x="5212080" y="1481328"/>
-            <a:ext cx="2971800" cy="274320"/>
-          </a:xfrm>
-          <a:prstGeom prst="rect">
-            <a:avLst/>
-          </a:prstGeom>
-          <a:solidFill>
-            <a:srgbClr val="2A2A2A"/>
-          </a:solidFill>
-          <a:ln>
-            <a:solidFill>
-              <a:srgbClr val="333333"/>
-            </a:solidFill>
-          </a:ln>
-        </p:spPr>
-        <p:style>
-          <a:lnRef idx="1">
-            <a:schemeClr val="accent1"/>
-          </a:lnRef>
-          <a:fillRef idx="3">
-            <a:schemeClr val="accent1"/>
-          </a:fillRef>
-          <a:effectRef idx="2">
-            <a:schemeClr val="accent1"/>
-          </a:effectRef>
-          <a:fontRef idx="minor">
-            <a:schemeClr val="lt1"/>
-          </a:fontRef>
-        </p:style>
-        <p:txBody>
-          <a:bodyPr rtlCol="0" anchor="ctr"/>
-          <a:lstStyle/>
-          <a:p>
-            <a:pPr algn="ctr"/>
-          </a:p>
-        </p:txBody>
-      </p:sp>
-      <p:sp>
-        <p:nvSpPr>
-          <p:cNvPr id="17" name="TextBox 16"/>
-          <p:cNvSpPr txBox="1"/>
-          <p:nvPr/>
-        </p:nvSpPr>
-        <p:spPr>
-          <a:xfrm>
-            <a:off x="5212080" y="1828800"/>
-            <a:ext cx="914400" cy="201168"/>
-          </a:xfrm>
-          <a:prstGeom prst="rect">
-            <a:avLst/>
-          </a:prstGeom>
-          <a:noFill/>
-        </p:spPr>
-        <p:txBody>
-          <a:bodyPr wrap="none">
-            <a:spAutoFit/>
-          </a:bodyPr>
-          <a:lstStyle/>
-          <a:p>
-            <a:pPr algn="l"/>
-            <a:r>
-              <a:rPr sz="800" b="0" i="0">
-                <a:solidFill>
-                  <a:srgbClr val="AAAAAA"/>
-                </a:solidFill>
-              </a:rPr>
-              <a:t>Date</a:t>
-            </a:r>
-          </a:p>
-        </p:txBody>
-      </p:sp>
-      <p:sp>
-        <p:nvSpPr>
-          <p:cNvPr id="18" name="Rectangle 17"/>
-          <p:cNvSpPr/>
-          <p:nvPr/>
-        </p:nvSpPr>
-        <p:spPr>
-          <a:xfrm>
-            <a:off x="5212080" y="2029968"/>
-            <a:ext cx="2971800" cy="274320"/>
-          </a:xfrm>
-          <a:prstGeom prst="rect">
-            <a:avLst/>
-          </a:prstGeom>
-          <a:solidFill>
-            <a:srgbClr val="2A2A2A"/>
-          </a:solidFill>
-          <a:ln>
-            <a:solidFill>
-              <a:srgbClr val="333333"/>
-            </a:solidFill>
-          </a:ln>
-        </p:spPr>
-        <p:style>
-          <a:lnRef idx="1">
-            <a:schemeClr val="accent1"/>
-          </a:lnRef>
-          <a:fillRef idx="3">
-            <a:schemeClr val="accent1"/>
-          </a:fillRef>
-          <a:effectRef idx="2">
-            <a:schemeClr val="accent1"/>
-          </a:effectRef>
-          <a:fontRef idx="minor">
-            <a:schemeClr val="lt1"/>
-          </a:fontRef>
-        </p:style>
-        <p:txBody>
-          <a:bodyPr rtlCol="0" anchor="ctr"/>
-          <a:lstStyle/>
-          <a:p>
-            <a:pPr algn="ctr"/>
-          </a:p>
-        </p:txBody>
-      </p:sp>
-      <p:sp>
-        <p:nvSpPr>
-          <p:cNvPr id="19" name="Rectangle 18"/>
-          <p:cNvSpPr/>
-          <p:nvPr/>
-        </p:nvSpPr>
-        <p:spPr>
-          <a:xfrm>
-            <a:off x="5212080" y="2423160"/>
-            <a:ext cx="2971800" cy="18288"/>
+            <a:off x="4572000" y="109728"/>
+            <a:ext cx="22860" cy="6638544"/>
           </a:xfrm>
           <a:prstGeom prst="rect">
             <a:avLst/>
@@ -3918,48 +3602,14 @@
       </p:sp>
       <p:sp>
         <p:nvSpPr>
-          <p:cNvPr id="20" name="TextBox 19"/>
-          <p:cNvSpPr txBox="1"/>
+          <p:cNvPr id="12" name="Rectangle 11"/>
+          <p:cNvSpPr/>
           <p:nvPr/>
         </p:nvSpPr>
         <p:spPr>
           <a:xfrm>
-            <a:off x="5212080" y="2514600"/>
-            <a:ext cx="2926080" cy="201168"/>
-          </a:xfrm>
-          <a:prstGeom prst="rect">
-            <a:avLst/>
-          </a:prstGeom>
-          <a:noFill/>
-        </p:spPr>
-        <p:txBody>
-          <a:bodyPr wrap="none">
-            <a:spAutoFit/>
-          </a:bodyPr>
-          <a:lstStyle/>
-          <a:p>
-            <a:pPr algn="l"/>
-            <a:r>
-              <a:rPr sz="800" b="1" i="0">
-                <a:solidFill>
-                  <a:srgbClr val="C0392B"/>
-                </a:solidFill>
-              </a:rPr>
-              <a:t>TOP 3 PRIORITIES</a:t>
-            </a:r>
-          </a:p>
-        </p:txBody>
-      </p:sp>
-      <p:sp>
-        <p:nvSpPr>
-          <p:cNvPr id="21" name="Rectangle 20"/>
-          <p:cNvSpPr/>
-          <p:nvPr/>
-        </p:nvSpPr>
-        <p:spPr>
-          <a:xfrm>
-            <a:off x="5212080" y="2770632"/>
-            <a:ext cx="914400" cy="237744"/>
+            <a:off x="4754880" y="658368"/>
+            <a:ext cx="2506846" cy="228600"/>
           </a:xfrm>
           <a:prstGeom prst="rect">
             <a:avLst/>
@@ -3997,14 +3647,14 @@
       </p:sp>
       <p:sp>
         <p:nvSpPr>
-          <p:cNvPr id="22" name="TextBox 21"/>
+          <p:cNvPr id="13" name="TextBox 12"/>
           <p:cNvSpPr txBox="1"/>
           <p:nvPr/>
         </p:nvSpPr>
         <p:spPr>
           <a:xfrm>
-            <a:off x="5257800" y="2788920"/>
-            <a:ext cx="822960" cy="219456"/>
+            <a:off x="4754880" y="667512"/>
+            <a:ext cx="2506846" cy="219456"/>
           </a:xfrm>
           <a:prstGeom prst="rect">
             <a:avLst/>
@@ -4019,26 +3669,26 @@
           <a:p>
             <a:pPr algn="ctr"/>
             <a:r>
-              <a:rPr sz="900" b="0" i="0">
+              <a:rPr sz="800" b="1" i="0">
                 <a:solidFill>
                   <a:srgbClr val="F0F0F0"/>
                 </a:solidFill>
               </a:rPr>
-              <a:t>① Price</a:t>
-            </a:r>
-          </a:p>
-        </p:txBody>
-      </p:sp>
-      <p:sp>
-        <p:nvSpPr>
-          <p:cNvPr id="23" name="Rectangle 22"/>
+              <a:t>SEARCH INTERFACE</a:t>
+            </a:r>
+          </a:p>
+        </p:txBody>
+      </p:sp>
+      <p:sp>
+        <p:nvSpPr>
+          <p:cNvPr id="14" name="Rectangle 13"/>
           <p:cNvSpPr/>
           <p:nvPr/>
         </p:nvSpPr>
         <p:spPr>
           <a:xfrm>
-            <a:off x="6217920" y="2770632"/>
-            <a:ext cx="914400" cy="237744"/>
+            <a:off x="7462894" y="658368"/>
+            <a:ext cx="4126160" cy="228600"/>
           </a:xfrm>
           <a:prstGeom prst="rect">
             <a:avLst/>
@@ -4076,14 +3726,14 @@
       </p:sp>
       <p:sp>
         <p:nvSpPr>
-          <p:cNvPr id="24" name="TextBox 23"/>
+          <p:cNvPr id="15" name="TextBox 14"/>
           <p:cNvSpPr txBox="1"/>
           <p:nvPr/>
         </p:nvSpPr>
         <p:spPr>
           <a:xfrm>
-            <a:off x="6263640" y="2788920"/>
-            <a:ext cx="822960" cy="219456"/>
+            <a:off x="7462894" y="667512"/>
+            <a:ext cx="4126160" cy="219456"/>
           </a:xfrm>
           <a:prstGeom prst="rect">
             <a:avLst/>
@@ -4098,36 +3748,82 @@
           <a:p>
             <a:pPr algn="ctr"/>
             <a:r>
-              <a:rPr sz="900" b="0" i="0">
+              <a:rPr sz="800" b="1" i="0">
                 <a:solidFill>
                   <a:srgbClr val="F0F0F0"/>
                 </a:solidFill>
               </a:rPr>
-              <a:t>② Duration</a:t>
-            </a:r>
-          </a:p>
-        </p:txBody>
-      </p:sp>
-      <p:sp>
-        <p:nvSpPr>
-          <p:cNvPr id="25" name="Rectangle 24"/>
-          <p:cNvSpPr/>
+              <a:t>RANKED RESULTS</a:t>
+            </a:r>
+          </a:p>
+        </p:txBody>
+      </p:sp>
+      <p:pic>
+        <p:nvPicPr>
+          <p:cNvPr id="16" name="Picture 15" descr="Skycompare2.png"/>
+          <p:cNvPicPr>
+            <a:picLocks noChangeAspect="1"/>
+          </p:cNvPicPr>
           <p:nvPr/>
-        </p:nvSpPr>
+        </p:nvPicPr>
+        <p:blipFill>
+          <a:blip r:embed="rId2"/>
+          <a:stretch>
+            <a:fillRect/>
+          </a:stretch>
+        </p:blipFill>
         <p:spPr>
           <a:xfrm>
-            <a:off x="7223760" y="2770632"/>
-            <a:ext cx="914400" cy="237744"/>
+            <a:off x="4754880" y="914400"/>
+            <a:ext cx="2506847" cy="2971800"/>
           </a:xfrm>
           <a:prstGeom prst="rect">
             <a:avLst/>
           </a:prstGeom>
-          <a:solidFill>
-            <a:srgbClr val="2A0A0A"/>
-          </a:solidFill>
+        </p:spPr>
+      </p:pic>
+      <p:pic>
+        <p:nvPicPr>
+          <p:cNvPr id="17" name="Picture 16" descr="Skycompare1.png"/>
+          <p:cNvPicPr>
+            <a:picLocks noChangeAspect="1"/>
+          </p:cNvPicPr>
+          <p:nvPr/>
+        </p:nvPicPr>
+        <p:blipFill>
+          <a:blip r:embed="rId3"/>
+          <a:stretch>
+            <a:fillRect/>
+          </a:stretch>
+        </p:blipFill>
+        <p:spPr>
+          <a:xfrm>
+            <a:off x="7462894" y="914400"/>
+            <a:ext cx="4126160" cy="2971800"/>
+          </a:xfrm>
+          <a:prstGeom prst="rect">
+            <a:avLst/>
+          </a:prstGeom>
+        </p:spPr>
+      </p:pic>
+      <p:sp>
+        <p:nvSpPr>
+          <p:cNvPr id="18" name="Rectangle 17"/>
+          <p:cNvSpPr/>
+          <p:nvPr/>
+        </p:nvSpPr>
+        <p:spPr>
+          <a:xfrm>
+            <a:off x="4754880" y="914400"/>
+            <a:ext cx="2506846" cy="2971800"/>
+          </a:xfrm>
+          <a:prstGeom prst="rect">
+            <a:avLst/>
+          </a:prstGeom>
+          <a:noFill/>
           <a:ln>
             <a:solidFill>
-              <a:srgbClr val="C0392B"/>
+              <a:srgbClr val="333333"/>
             </a:solidFill>
           </a:ln>
         </p:spPr>
@@ -4155,165 +3851,20 @@
       </p:sp>
       <p:sp>
         <p:nvSpPr>
-          <p:cNvPr id="26" name="TextBox 25"/>
-          <p:cNvSpPr txBox="1"/>
+          <p:cNvPr id="19" name="Rectangle 18"/>
+          <p:cNvSpPr/>
           <p:nvPr/>
         </p:nvSpPr>
         <p:spPr>
           <a:xfrm>
-            <a:off x="7269480" y="2788920"/>
-            <a:ext cx="822960" cy="219456"/>
-          </a:xfrm>
-          <a:prstGeom prst="rect">
-            <a:avLst/>
-          </a:prstGeom>
-          <a:noFill/>
-        </p:spPr>
-        <p:txBody>
-          <a:bodyPr wrap="none">
-            <a:spAutoFit/>
-          </a:bodyPr>
-          <a:lstStyle/>
-          <a:p>
-            <a:pPr algn="ctr"/>
-            <a:r>
-              <a:rPr sz="900" b="0" i="0">
-                <a:solidFill>
-                  <a:srgbClr val="F0F0F0"/>
-                </a:solidFill>
-              </a:rPr>
-              <a:t>③ Direct</a:t>
-            </a:r>
-          </a:p>
-        </p:txBody>
-      </p:sp>
-      <p:sp>
-        <p:nvSpPr>
-          <p:cNvPr id="27" name="Rectangle 26"/>
-          <p:cNvSpPr/>
-          <p:nvPr/>
-        </p:nvSpPr>
-        <p:spPr>
-          <a:xfrm>
-            <a:off x="5212080" y="3154680"/>
-            <a:ext cx="2971800" cy="274320"/>
+            <a:off x="7462894" y="914400"/>
+            <a:ext cx="4126160" cy="2971800"/>
           </a:xfrm>
           <a:prstGeom prst="rect">
             <a:avLst/>
           </a:prstGeom>
           <a:solidFill>
-            <a:srgbClr val="C0392B"/>
-          </a:solidFill>
-          <a:ln>
-            <a:noFill/>
-          </a:ln>
-        </p:spPr>
-        <p:style>
-          <a:lnRef idx="1">
-            <a:schemeClr val="accent1"/>
-          </a:lnRef>
-          <a:fillRef idx="3">
-            <a:schemeClr val="accent1"/>
-          </a:fillRef>
-          <a:effectRef idx="2">
-            <a:schemeClr val="accent1"/>
-          </a:effectRef>
-          <a:fontRef idx="minor">
-            <a:schemeClr val="lt1"/>
-          </a:fontRef>
-        </p:style>
-        <p:txBody>
-          <a:bodyPr rtlCol="0" anchor="ctr"/>
-          <a:lstStyle/>
-          <a:p>
-            <a:pPr algn="ctr"/>
-          </a:p>
-        </p:txBody>
-      </p:sp>
-      <p:sp>
-        <p:nvSpPr>
-          <p:cNvPr id="28" name="TextBox 27"/>
-          <p:cNvSpPr txBox="1"/>
-          <p:nvPr/>
-        </p:nvSpPr>
-        <p:spPr>
-          <a:xfrm>
-            <a:off x="5212080" y="3154680"/>
-            <a:ext cx="2971800" cy="274320"/>
-          </a:xfrm>
-          <a:prstGeom prst="rect">
-            <a:avLst/>
-          </a:prstGeom>
-          <a:noFill/>
-        </p:spPr>
-        <p:txBody>
-          <a:bodyPr wrap="none">
-            <a:spAutoFit/>
-          </a:bodyPr>
-          <a:lstStyle/>
-          <a:p>
-            <a:pPr algn="ctr"/>
-            <a:r>
-              <a:rPr sz="1000" b="1" i="0">
-                <a:solidFill>
-                  <a:srgbClr val="FFFFFF"/>
-                </a:solidFill>
-              </a:rPr>
-              <a:t>Find My Best Flight</a:t>
-            </a:r>
-          </a:p>
-        </p:txBody>
-      </p:sp>
-      <p:sp>
-        <p:nvSpPr>
-          <p:cNvPr id="29" name="TextBox 28"/>
-          <p:cNvSpPr txBox="1"/>
-          <p:nvPr/>
-        </p:nvSpPr>
-        <p:spPr>
-          <a:xfrm>
-            <a:off x="5074920" y="3593592"/>
-            <a:ext cx="3246120" cy="201168"/>
-          </a:xfrm>
-          <a:prstGeom prst="rect">
-            <a:avLst/>
-          </a:prstGeom>
-          <a:noFill/>
-        </p:spPr>
-        <p:txBody>
-          <a:bodyPr wrap="none">
-            <a:spAutoFit/>
-          </a:bodyPr>
-          <a:lstStyle/>
-          <a:p>
-            <a:pPr algn="ctr"/>
-            <a:r>
-              <a:rPr sz="900" b="0" i="1">
-                <a:solidFill>
-                  <a:srgbClr val="AAAAAA"/>
-                </a:solidFill>
-              </a:rPr>
-              <a:t>Search Interface</a:t>
-            </a:r>
-          </a:p>
-        </p:txBody>
-      </p:sp>
-      <p:sp>
-        <p:nvSpPr>
-          <p:cNvPr id="30" name="Rectangle 29"/>
-          <p:cNvSpPr/>
-          <p:nvPr/>
-        </p:nvSpPr>
-        <p:spPr>
-          <a:xfrm>
-            <a:off x="8595360" y="320040"/>
-            <a:ext cx="3291840" cy="6172200"/>
-          </a:xfrm>
-          <a:prstGeom prst="rect">
-            <a:avLst/>
-          </a:prstGeom>
-          <a:solidFill>
-            <a:srgbClr val="1E1E1E"/>
+            <a:srgbClr val="000000"/>
           </a:solidFill>
           <a:ln>
             <a:solidFill>
@@ -4345,14 +3896,14 @@
       </p:sp>
       <p:sp>
         <p:nvSpPr>
-          <p:cNvPr id="31" name="TextBox 30"/>
+          <p:cNvPr id="20" name="TextBox 19"/>
           <p:cNvSpPr txBox="1"/>
           <p:nvPr/>
         </p:nvSpPr>
         <p:spPr>
           <a:xfrm>
-            <a:off x="8732520" y="429768"/>
-            <a:ext cx="3017520" cy="228600"/>
+            <a:off x="4754880" y="4050792"/>
+            <a:ext cx="7251192" cy="822960"/>
           </a:xfrm>
           <a:prstGeom prst="rect">
             <a:avLst/>
@@ -4360,1710 +3911,19 @@
           <a:noFill/>
         </p:spPr>
         <p:txBody>
-          <a:bodyPr wrap="none">
+          <a:bodyPr wrap="square">
             <a:spAutoFit/>
           </a:bodyPr>
           <a:lstStyle/>
           <a:p>
             <a:pPr algn="l"/>
             <a:r>
-              <a:rPr sz="800" b="1" i="0">
-                <a:solidFill>
-                  <a:srgbClr val="C0392B"/>
-                </a:solidFill>
-              </a:rPr>
-              <a:t>SKYCOMPARE RESULTS</a:t>
-            </a:r>
-          </a:p>
-        </p:txBody>
-      </p:sp>
-      <p:sp>
-        <p:nvSpPr>
-          <p:cNvPr id="32" name="TextBox 31"/>
-          <p:cNvSpPr txBox="1"/>
-          <p:nvPr/>
-        </p:nvSpPr>
-        <p:spPr>
-          <a:xfrm>
-            <a:off x="8732520" y="685800"/>
-            <a:ext cx="3017520" cy="201168"/>
-          </a:xfrm>
-          <a:prstGeom prst="rect">
-            <a:avLst/>
-          </a:prstGeom>
-          <a:noFill/>
-        </p:spPr>
-        <p:txBody>
-          <a:bodyPr wrap="none">
-            <a:spAutoFit/>
-          </a:bodyPr>
-          <a:lstStyle/>
-          <a:p>
-            <a:pPr algn="l"/>
-            <a:r>
-              <a:rPr sz="900" b="0" i="0">
+              <a:rPr sz="1000" b="0" i="1">
                 <a:solidFill>
                   <a:srgbClr val="AAAAAA"/>
                 </a:solidFill>
               </a:rPr>
-              <a:t>ATL  →  LAX   ·   2026-05-10</a:t>
-            </a:r>
-          </a:p>
-        </p:txBody>
-      </p:sp>
-      <p:sp>
-        <p:nvSpPr>
-          <p:cNvPr id="33" name="Rectangle 32"/>
-          <p:cNvSpPr/>
-          <p:nvPr/>
-        </p:nvSpPr>
-        <p:spPr>
-          <a:xfrm>
-            <a:off x="8732520" y="941832"/>
-            <a:ext cx="960120" cy="201168"/>
-          </a:xfrm>
-          <a:prstGeom prst="rect">
-            <a:avLst/>
-          </a:prstGeom>
-          <a:solidFill>
-            <a:srgbClr val="2A0A0A"/>
-          </a:solidFill>
-          <a:ln>
-            <a:solidFill>
-              <a:srgbClr val="C0392B"/>
-            </a:solidFill>
-          </a:ln>
-        </p:spPr>
-        <p:style>
-          <a:lnRef idx="1">
-            <a:schemeClr val="accent1"/>
-          </a:lnRef>
-          <a:fillRef idx="3">
-            <a:schemeClr val="accent1"/>
-          </a:fillRef>
-          <a:effectRef idx="2">
-            <a:schemeClr val="accent1"/>
-          </a:effectRef>
-          <a:fontRef idx="minor">
-            <a:schemeClr val="lt1"/>
-          </a:fontRef>
-        </p:style>
-        <p:txBody>
-          <a:bodyPr rtlCol="0" anchor="ctr"/>
-          <a:lstStyle/>
-          <a:p>
-            <a:pPr algn="ctr"/>
-          </a:p>
-        </p:txBody>
-      </p:sp>
-      <p:sp>
-        <p:nvSpPr>
-          <p:cNvPr id="34" name="TextBox 33"/>
-          <p:cNvSpPr txBox="1"/>
-          <p:nvPr/>
-        </p:nvSpPr>
-        <p:spPr>
-          <a:xfrm>
-            <a:off x="8769096" y="950976"/>
-            <a:ext cx="886968" cy="201168"/>
-          </a:xfrm>
-          <a:prstGeom prst="rect">
-            <a:avLst/>
-          </a:prstGeom>
-          <a:noFill/>
-        </p:spPr>
-        <p:txBody>
-          <a:bodyPr wrap="none">
-            <a:spAutoFit/>
-          </a:bodyPr>
-          <a:lstStyle/>
-          <a:p>
-            <a:pPr algn="ctr"/>
-            <a:r>
-              <a:rPr sz="800" b="0" i="0">
-                <a:solidFill>
-                  <a:srgbClr val="F0F0F0"/>
-                </a:solidFill>
-              </a:rPr>
-              <a:t>#1 Price</a:t>
-            </a:r>
-          </a:p>
-        </p:txBody>
-      </p:sp>
-      <p:sp>
-        <p:nvSpPr>
-          <p:cNvPr id="35" name="Rectangle 34"/>
-          <p:cNvSpPr/>
-          <p:nvPr/>
-        </p:nvSpPr>
-        <p:spPr>
-          <a:xfrm>
-            <a:off x="9784079" y="941832"/>
-            <a:ext cx="960120" cy="201168"/>
-          </a:xfrm>
-          <a:prstGeom prst="rect">
-            <a:avLst/>
-          </a:prstGeom>
-          <a:solidFill>
-            <a:srgbClr val="2A0A0A"/>
-          </a:solidFill>
-          <a:ln>
-            <a:solidFill>
-              <a:srgbClr val="C0392B"/>
-            </a:solidFill>
-          </a:ln>
-        </p:spPr>
-        <p:style>
-          <a:lnRef idx="1">
-            <a:schemeClr val="accent1"/>
-          </a:lnRef>
-          <a:fillRef idx="3">
-            <a:schemeClr val="accent1"/>
-          </a:fillRef>
-          <a:effectRef idx="2">
-            <a:schemeClr val="accent1"/>
-          </a:effectRef>
-          <a:fontRef idx="minor">
-            <a:schemeClr val="lt1"/>
-          </a:fontRef>
-        </p:style>
-        <p:txBody>
-          <a:bodyPr rtlCol="0" anchor="ctr"/>
-          <a:lstStyle/>
-          <a:p>
-            <a:pPr algn="ctr"/>
-          </a:p>
-        </p:txBody>
-      </p:sp>
-      <p:sp>
-        <p:nvSpPr>
-          <p:cNvPr id="36" name="TextBox 35"/>
-          <p:cNvSpPr txBox="1"/>
-          <p:nvPr/>
-        </p:nvSpPr>
-        <p:spPr>
-          <a:xfrm>
-            <a:off x="9820655" y="950976"/>
-            <a:ext cx="886968" cy="201168"/>
-          </a:xfrm>
-          <a:prstGeom prst="rect">
-            <a:avLst/>
-          </a:prstGeom>
-          <a:noFill/>
-        </p:spPr>
-        <p:txBody>
-          <a:bodyPr wrap="none">
-            <a:spAutoFit/>
-          </a:bodyPr>
-          <a:lstStyle/>
-          <a:p>
-            <a:pPr algn="ctr"/>
-            <a:r>
-              <a:rPr sz="800" b="0" i="0">
-                <a:solidFill>
-                  <a:srgbClr val="F0F0F0"/>
-                </a:solidFill>
-              </a:rPr>
-              <a:t>#2 Duration</a:t>
-            </a:r>
-          </a:p>
-        </p:txBody>
-      </p:sp>
-      <p:sp>
-        <p:nvSpPr>
-          <p:cNvPr id="37" name="Rectangle 36"/>
-          <p:cNvSpPr/>
-          <p:nvPr/>
-        </p:nvSpPr>
-        <p:spPr>
-          <a:xfrm>
-            <a:off x="10835639" y="941832"/>
-            <a:ext cx="960120" cy="201168"/>
-          </a:xfrm>
-          <a:prstGeom prst="rect">
-            <a:avLst/>
-          </a:prstGeom>
-          <a:solidFill>
-            <a:srgbClr val="2A0A0A"/>
-          </a:solidFill>
-          <a:ln>
-            <a:solidFill>
-              <a:srgbClr val="C0392B"/>
-            </a:solidFill>
-          </a:ln>
-        </p:spPr>
-        <p:style>
-          <a:lnRef idx="1">
-            <a:schemeClr val="accent1"/>
-          </a:lnRef>
-          <a:fillRef idx="3">
-            <a:schemeClr val="accent1"/>
-          </a:fillRef>
-          <a:effectRef idx="2">
-            <a:schemeClr val="accent1"/>
-          </a:effectRef>
-          <a:fontRef idx="minor">
-            <a:schemeClr val="lt1"/>
-          </a:fontRef>
-        </p:style>
-        <p:txBody>
-          <a:bodyPr rtlCol="0" anchor="ctr"/>
-          <a:lstStyle/>
-          <a:p>
-            <a:pPr algn="ctr"/>
-          </a:p>
-        </p:txBody>
-      </p:sp>
-      <p:sp>
-        <p:nvSpPr>
-          <p:cNvPr id="38" name="TextBox 37"/>
-          <p:cNvSpPr txBox="1"/>
-          <p:nvPr/>
-        </p:nvSpPr>
-        <p:spPr>
-          <a:xfrm>
-            <a:off x="10872215" y="950976"/>
-            <a:ext cx="886968" cy="201168"/>
-          </a:xfrm>
-          <a:prstGeom prst="rect">
-            <a:avLst/>
-          </a:prstGeom>
-          <a:noFill/>
-        </p:spPr>
-        <p:txBody>
-          <a:bodyPr wrap="none">
-            <a:spAutoFit/>
-          </a:bodyPr>
-          <a:lstStyle/>
-          <a:p>
-            <a:pPr algn="ctr"/>
-            <a:r>
-              <a:rPr sz="800" b="0" i="0">
-                <a:solidFill>
-                  <a:srgbClr val="F0F0F0"/>
-                </a:solidFill>
-              </a:rPr>
-              <a:t>#3 Direct</a:t>
-            </a:r>
-          </a:p>
-        </p:txBody>
-      </p:sp>
-      <p:sp>
-        <p:nvSpPr>
-          <p:cNvPr id="39" name="Rectangle 38"/>
-          <p:cNvSpPr/>
-          <p:nvPr/>
-        </p:nvSpPr>
-        <p:spPr>
-          <a:xfrm>
-            <a:off x="8686800" y="1234440"/>
-            <a:ext cx="3108960" cy="237744"/>
-          </a:xfrm>
-          <a:prstGeom prst="rect">
-            <a:avLst/>
-          </a:prstGeom>
-          <a:solidFill>
-            <a:srgbClr val="1C1C1C"/>
-          </a:solidFill>
-          <a:ln>
-            <a:noFill/>
-          </a:ln>
-        </p:spPr>
-        <p:style>
-          <a:lnRef idx="1">
-            <a:schemeClr val="accent1"/>
-          </a:lnRef>
-          <a:fillRef idx="3">
-            <a:schemeClr val="accent1"/>
-          </a:fillRef>
-          <a:effectRef idx="2">
-            <a:schemeClr val="accent1"/>
-          </a:effectRef>
-          <a:fontRef idx="minor">
-            <a:schemeClr val="lt1"/>
-          </a:fontRef>
-        </p:style>
-        <p:txBody>
-          <a:bodyPr rtlCol="0" anchor="ctr"/>
-          <a:lstStyle/>
-          <a:p>
-            <a:pPr algn="ctr"/>
-          </a:p>
-        </p:txBody>
-      </p:sp>
-      <p:sp>
-        <p:nvSpPr>
-          <p:cNvPr id="40" name="TextBox 39"/>
-          <p:cNvSpPr txBox="1"/>
-          <p:nvPr/>
-        </p:nvSpPr>
-        <p:spPr>
-          <a:xfrm>
-            <a:off x="8732520" y="1243584"/>
-            <a:ext cx="3017520" cy="219456"/>
-          </a:xfrm>
-          <a:prstGeom prst="rect">
-            <a:avLst/>
-          </a:prstGeom>
-          <a:noFill/>
-        </p:spPr>
-        <p:txBody>
-          <a:bodyPr wrap="none">
-            <a:spAutoFit/>
-          </a:bodyPr>
-          <a:lstStyle/>
-          <a:p>
-            <a:pPr algn="l"/>
-            <a:r>
-              <a:rPr sz="800" b="1" i="0">
-                <a:solidFill>
-                  <a:srgbClr val="AAAAAA"/>
-                </a:solidFill>
-              </a:rPr>
-              <a:t>Rank   Airline        Score   Price   Book</a:t>
-            </a:r>
-          </a:p>
-        </p:txBody>
-      </p:sp>
-      <p:sp>
-        <p:nvSpPr>
-          <p:cNvPr id="41" name="Rectangle 40"/>
-          <p:cNvSpPr/>
-          <p:nvPr/>
-        </p:nvSpPr>
-        <p:spPr>
-          <a:xfrm>
-            <a:off x="8686800" y="1527048"/>
-            <a:ext cx="3108960" cy="822960"/>
-          </a:xfrm>
-          <a:prstGeom prst="rect">
-            <a:avLst/>
-          </a:prstGeom>
-          <a:solidFill>
-            <a:srgbClr val="2A0A0A"/>
-          </a:solidFill>
-          <a:ln>
-            <a:solidFill>
-              <a:srgbClr val="C0392B"/>
-            </a:solidFill>
-          </a:ln>
-        </p:spPr>
-        <p:style>
-          <a:lnRef idx="1">
-            <a:schemeClr val="accent1"/>
-          </a:lnRef>
-          <a:fillRef idx="3">
-            <a:schemeClr val="accent1"/>
-          </a:fillRef>
-          <a:effectRef idx="2">
-            <a:schemeClr val="accent1"/>
-          </a:effectRef>
-          <a:fontRef idx="minor">
-            <a:schemeClr val="lt1"/>
-          </a:fontRef>
-        </p:style>
-        <p:txBody>
-          <a:bodyPr rtlCol="0" anchor="ctr"/>
-          <a:lstStyle/>
-          <a:p>
-            <a:pPr algn="ctr"/>
-          </a:p>
-        </p:txBody>
-      </p:sp>
-      <p:sp>
-        <p:nvSpPr>
-          <p:cNvPr id="42" name="TextBox 41"/>
-          <p:cNvSpPr txBox="1"/>
-          <p:nvPr/>
-        </p:nvSpPr>
-        <p:spPr>
-          <a:xfrm>
-            <a:off x="8759952" y="1581912"/>
-            <a:ext cx="347472" cy="274320"/>
-          </a:xfrm>
-          <a:prstGeom prst="rect">
-            <a:avLst/>
-          </a:prstGeom>
-          <a:noFill/>
-        </p:spPr>
-        <p:txBody>
-          <a:bodyPr wrap="none">
-            <a:spAutoFit/>
-          </a:bodyPr>
-          <a:lstStyle/>
-          <a:p>
-            <a:pPr algn="l"/>
-            <a:r>
-              <a:rPr sz="900" b="1" i="0">
-                <a:solidFill>
-                  <a:srgbClr val="AAAAAA"/>
-                </a:solidFill>
-              </a:rPr>
-              <a:t>#1</a:t>
-            </a:r>
-          </a:p>
-        </p:txBody>
-      </p:sp>
-      <p:sp>
-        <p:nvSpPr>
-          <p:cNvPr id="43" name="TextBox 42"/>
-          <p:cNvSpPr txBox="1"/>
-          <p:nvPr/>
-        </p:nvSpPr>
-        <p:spPr>
-          <a:xfrm>
-            <a:off x="9125712" y="1581912"/>
-            <a:ext cx="1097280" cy="274320"/>
-          </a:xfrm>
-          <a:prstGeom prst="rect">
-            <a:avLst/>
-          </a:prstGeom>
-          <a:noFill/>
-        </p:spPr>
-        <p:txBody>
-          <a:bodyPr wrap="none">
-            <a:spAutoFit/>
-          </a:bodyPr>
-          <a:lstStyle/>
-          <a:p>
-            <a:pPr algn="l"/>
-            <a:r>
-              <a:rPr sz="900" b="1" i="0">
-                <a:solidFill>
-                  <a:srgbClr val="F0F0F0"/>
-                </a:solidFill>
-              </a:rPr>
-              <a:t>✈ Southwest</a:t>
-            </a:r>
-          </a:p>
-        </p:txBody>
-      </p:sp>
-      <p:sp>
-        <p:nvSpPr>
-          <p:cNvPr id="44" name="Rectangle 43"/>
-          <p:cNvSpPr/>
-          <p:nvPr/>
-        </p:nvSpPr>
-        <p:spPr>
-          <a:xfrm>
-            <a:off x="9125712" y="1929384"/>
-            <a:ext cx="530352" cy="237744"/>
-          </a:xfrm>
-          <a:prstGeom prst="rect">
-            <a:avLst/>
-          </a:prstGeom>
-          <a:solidFill>
-            <a:srgbClr val="C0392B"/>
-          </a:solidFill>
-          <a:ln>
-            <a:noFill/>
-          </a:ln>
-        </p:spPr>
-        <p:style>
-          <a:lnRef idx="1">
-            <a:schemeClr val="accent1"/>
-          </a:lnRef>
-          <a:fillRef idx="3">
-            <a:schemeClr val="accent1"/>
-          </a:fillRef>
-          <a:effectRef idx="2">
-            <a:schemeClr val="accent1"/>
-          </a:effectRef>
-          <a:fontRef idx="minor">
-            <a:schemeClr val="lt1"/>
-          </a:fontRef>
-        </p:style>
-        <p:txBody>
-          <a:bodyPr rtlCol="0" anchor="ctr"/>
-          <a:lstStyle/>
-          <a:p>
-            <a:pPr algn="ctr"/>
-          </a:p>
-        </p:txBody>
-      </p:sp>
-      <p:sp>
-        <p:nvSpPr>
-          <p:cNvPr id="45" name="TextBox 44"/>
-          <p:cNvSpPr txBox="1"/>
-          <p:nvPr/>
-        </p:nvSpPr>
-        <p:spPr>
-          <a:xfrm>
-            <a:off x="9125712" y="1929384"/>
-            <a:ext cx="530352" cy="237744"/>
-          </a:xfrm>
-          <a:prstGeom prst="rect">
-            <a:avLst/>
-          </a:prstGeom>
-          <a:noFill/>
-        </p:spPr>
-        <p:txBody>
-          <a:bodyPr wrap="none">
-            <a:spAutoFit/>
-          </a:bodyPr>
-          <a:lstStyle/>
-          <a:p>
-            <a:pPr algn="ctr"/>
-            <a:r>
-              <a:rPr sz="800" b="1" i="0">
-                <a:solidFill>
-                  <a:srgbClr val="FFFFFF"/>
-                </a:solidFill>
-              </a:rPr>
-              <a:t>87.4</a:t>
-            </a:r>
-          </a:p>
-        </p:txBody>
-      </p:sp>
-      <p:sp>
-        <p:nvSpPr>
-          <p:cNvPr id="46" name="TextBox 45"/>
-          <p:cNvSpPr txBox="1"/>
-          <p:nvPr/>
-        </p:nvSpPr>
-        <p:spPr>
-          <a:xfrm>
-            <a:off x="9710928" y="1581912"/>
-            <a:ext cx="548640" cy="274320"/>
-          </a:xfrm>
-          <a:prstGeom prst="rect">
-            <a:avLst/>
-          </a:prstGeom>
-          <a:noFill/>
-        </p:spPr>
-        <p:txBody>
-          <a:bodyPr wrap="none">
-            <a:spAutoFit/>
-          </a:bodyPr>
-          <a:lstStyle/>
-          <a:p>
-            <a:pPr algn="l"/>
-            <a:r>
-              <a:rPr sz="900" b="0" i="0">
-                <a:solidFill>
-                  <a:srgbClr val="F0F0F0"/>
-                </a:solidFill>
-              </a:rPr>
-              <a:t>$189</a:t>
-            </a:r>
-          </a:p>
-        </p:txBody>
-      </p:sp>
-      <p:sp>
-        <p:nvSpPr>
-          <p:cNvPr id="47" name="Rectangle 46"/>
-          <p:cNvSpPr/>
-          <p:nvPr/>
-        </p:nvSpPr>
-        <p:spPr>
-          <a:xfrm>
-            <a:off x="11109960" y="1581912"/>
-            <a:ext cx="566928" cy="237744"/>
-          </a:xfrm>
-          <a:prstGeom prst="rect">
-            <a:avLst/>
-          </a:prstGeom>
-          <a:solidFill>
-            <a:srgbClr val="C0392B"/>
-          </a:solidFill>
-          <a:ln>
-            <a:noFill/>
-          </a:ln>
-        </p:spPr>
-        <p:style>
-          <a:lnRef idx="1">
-            <a:schemeClr val="accent1"/>
-          </a:lnRef>
-          <a:fillRef idx="3">
-            <a:schemeClr val="accent1"/>
-          </a:fillRef>
-          <a:effectRef idx="2">
-            <a:schemeClr val="accent1"/>
-          </a:effectRef>
-          <a:fontRef idx="minor">
-            <a:schemeClr val="lt1"/>
-          </a:fontRef>
-        </p:style>
-        <p:txBody>
-          <a:bodyPr rtlCol="0" anchor="ctr"/>
-          <a:lstStyle/>
-          <a:p>
-            <a:pPr algn="ctr"/>
-          </a:p>
-        </p:txBody>
-      </p:sp>
-      <p:sp>
-        <p:nvSpPr>
-          <p:cNvPr id="48" name="TextBox 47"/>
-          <p:cNvSpPr txBox="1"/>
-          <p:nvPr/>
-        </p:nvSpPr>
-        <p:spPr>
-          <a:xfrm>
-            <a:off x="11109960" y="1581912"/>
-            <a:ext cx="566928" cy="237744"/>
-          </a:xfrm>
-          <a:prstGeom prst="rect">
-            <a:avLst/>
-          </a:prstGeom>
-          <a:noFill/>
-        </p:spPr>
-        <p:txBody>
-          <a:bodyPr wrap="none">
-            <a:spAutoFit/>
-          </a:bodyPr>
-          <a:lstStyle/>
-          <a:p>
-            <a:pPr algn="ctr"/>
-            <a:r>
-              <a:rPr sz="800" b="1" i="0">
-                <a:solidFill>
-                  <a:srgbClr val="FFFFFF"/>
-                </a:solidFill>
-              </a:rPr>
-              <a:t>Book</a:t>
-            </a:r>
-          </a:p>
-        </p:txBody>
-      </p:sp>
-      <p:sp>
-        <p:nvSpPr>
-          <p:cNvPr id="49" name="Rectangle 48"/>
-          <p:cNvSpPr/>
-          <p:nvPr/>
-        </p:nvSpPr>
-        <p:spPr>
-          <a:xfrm>
-            <a:off x="8686800" y="2459736"/>
-            <a:ext cx="3108960" cy="822960"/>
-          </a:xfrm>
-          <a:prstGeom prst="rect">
-            <a:avLst/>
-          </a:prstGeom>
-          <a:solidFill>
-            <a:srgbClr val="222222"/>
-          </a:solidFill>
-          <a:ln>
-            <a:noFill/>
-          </a:ln>
-        </p:spPr>
-        <p:style>
-          <a:lnRef idx="1">
-            <a:schemeClr val="accent1"/>
-          </a:lnRef>
-          <a:fillRef idx="3">
-            <a:schemeClr val="accent1"/>
-          </a:fillRef>
-          <a:effectRef idx="2">
-            <a:schemeClr val="accent1"/>
-          </a:effectRef>
-          <a:fontRef idx="minor">
-            <a:schemeClr val="lt1"/>
-          </a:fontRef>
-        </p:style>
-        <p:txBody>
-          <a:bodyPr rtlCol="0" anchor="ctr"/>
-          <a:lstStyle/>
-          <a:p>
-            <a:pPr algn="ctr"/>
-          </a:p>
-        </p:txBody>
-      </p:sp>
-      <p:sp>
-        <p:nvSpPr>
-          <p:cNvPr id="50" name="TextBox 49"/>
-          <p:cNvSpPr txBox="1"/>
-          <p:nvPr/>
-        </p:nvSpPr>
-        <p:spPr>
-          <a:xfrm>
-            <a:off x="8759952" y="2514600"/>
-            <a:ext cx="347472" cy="274320"/>
-          </a:xfrm>
-          <a:prstGeom prst="rect">
-            <a:avLst/>
-          </a:prstGeom>
-          <a:noFill/>
-        </p:spPr>
-        <p:txBody>
-          <a:bodyPr wrap="none">
-            <a:spAutoFit/>
-          </a:bodyPr>
-          <a:lstStyle/>
-          <a:p>
-            <a:pPr algn="l"/>
-            <a:r>
-              <a:rPr sz="900" b="1" i="0">
-                <a:solidFill>
-                  <a:srgbClr val="AAAAAA"/>
-                </a:solidFill>
-              </a:rPr>
-              <a:t>#2</a:t>
-            </a:r>
-          </a:p>
-        </p:txBody>
-      </p:sp>
-      <p:sp>
-        <p:nvSpPr>
-          <p:cNvPr id="51" name="TextBox 50"/>
-          <p:cNvSpPr txBox="1"/>
-          <p:nvPr/>
-        </p:nvSpPr>
-        <p:spPr>
-          <a:xfrm>
-            <a:off x="9125712" y="2514600"/>
-            <a:ext cx="1097280" cy="274320"/>
-          </a:xfrm>
-          <a:prstGeom prst="rect">
-            <a:avLst/>
-          </a:prstGeom>
-          <a:noFill/>
-        </p:spPr>
-        <p:txBody>
-          <a:bodyPr wrap="none">
-            <a:spAutoFit/>
-          </a:bodyPr>
-          <a:lstStyle/>
-          <a:p>
-            <a:pPr algn="l"/>
-            <a:r>
-              <a:rPr sz="900" b="1" i="0">
-                <a:solidFill>
-                  <a:srgbClr val="F0F0F0"/>
-                </a:solidFill>
-              </a:rPr>
-              <a:t>✈ Delta</a:t>
-            </a:r>
-          </a:p>
-        </p:txBody>
-      </p:sp>
-      <p:sp>
-        <p:nvSpPr>
-          <p:cNvPr id="52" name="Rectangle 51"/>
-          <p:cNvSpPr/>
-          <p:nvPr/>
-        </p:nvSpPr>
-        <p:spPr>
-          <a:xfrm>
-            <a:off x="9125712" y="2862072"/>
-            <a:ext cx="530352" cy="237744"/>
-          </a:xfrm>
-          <a:prstGeom prst="rect">
-            <a:avLst/>
-          </a:prstGeom>
-          <a:solidFill>
-            <a:srgbClr val="555555"/>
-          </a:solidFill>
-          <a:ln>
-            <a:noFill/>
-          </a:ln>
-        </p:spPr>
-        <p:style>
-          <a:lnRef idx="1">
-            <a:schemeClr val="accent1"/>
-          </a:lnRef>
-          <a:fillRef idx="3">
-            <a:schemeClr val="accent1"/>
-          </a:fillRef>
-          <a:effectRef idx="2">
-            <a:schemeClr val="accent1"/>
-          </a:effectRef>
-          <a:fontRef idx="minor">
-            <a:schemeClr val="lt1"/>
-          </a:fontRef>
-        </p:style>
-        <p:txBody>
-          <a:bodyPr rtlCol="0" anchor="ctr"/>
-          <a:lstStyle/>
-          <a:p>
-            <a:pPr algn="ctr"/>
-          </a:p>
-        </p:txBody>
-      </p:sp>
-      <p:sp>
-        <p:nvSpPr>
-          <p:cNvPr id="53" name="TextBox 52"/>
-          <p:cNvSpPr txBox="1"/>
-          <p:nvPr/>
-        </p:nvSpPr>
-        <p:spPr>
-          <a:xfrm>
-            <a:off x="9125712" y="2862072"/>
-            <a:ext cx="530352" cy="237744"/>
-          </a:xfrm>
-          <a:prstGeom prst="rect">
-            <a:avLst/>
-          </a:prstGeom>
-          <a:noFill/>
-        </p:spPr>
-        <p:txBody>
-          <a:bodyPr wrap="none">
-            <a:spAutoFit/>
-          </a:bodyPr>
-          <a:lstStyle/>
-          <a:p>
-            <a:pPr algn="ctr"/>
-            <a:r>
-              <a:rPr sz="800" b="1" i="0">
-                <a:solidFill>
-                  <a:srgbClr val="FFFFFF"/>
-                </a:solidFill>
-              </a:rPr>
-              <a:t>74.1</a:t>
-            </a:r>
-          </a:p>
-        </p:txBody>
-      </p:sp>
-      <p:sp>
-        <p:nvSpPr>
-          <p:cNvPr id="54" name="TextBox 53"/>
-          <p:cNvSpPr txBox="1"/>
-          <p:nvPr/>
-        </p:nvSpPr>
-        <p:spPr>
-          <a:xfrm>
-            <a:off x="9710928" y="2514600"/>
-            <a:ext cx="548640" cy="274320"/>
-          </a:xfrm>
-          <a:prstGeom prst="rect">
-            <a:avLst/>
-          </a:prstGeom>
-          <a:noFill/>
-        </p:spPr>
-        <p:txBody>
-          <a:bodyPr wrap="none">
-            <a:spAutoFit/>
-          </a:bodyPr>
-          <a:lstStyle/>
-          <a:p>
-            <a:pPr algn="l"/>
-            <a:r>
-              <a:rPr sz="900" b="0" i="0">
-                <a:solidFill>
-                  <a:srgbClr val="F0F0F0"/>
-                </a:solidFill>
-              </a:rPr>
-              <a:t>$312</a:t>
-            </a:r>
-          </a:p>
-        </p:txBody>
-      </p:sp>
-      <p:sp>
-        <p:nvSpPr>
-          <p:cNvPr id="55" name="Rectangle 54"/>
-          <p:cNvSpPr/>
-          <p:nvPr/>
-        </p:nvSpPr>
-        <p:spPr>
-          <a:xfrm>
-            <a:off x="8686800" y="3392424"/>
-            <a:ext cx="3108960" cy="822960"/>
-          </a:xfrm>
-          <a:prstGeom prst="rect">
-            <a:avLst/>
-          </a:prstGeom>
-          <a:solidFill>
-            <a:srgbClr val="222222"/>
-          </a:solidFill>
-          <a:ln>
-            <a:noFill/>
-          </a:ln>
-        </p:spPr>
-        <p:style>
-          <a:lnRef idx="1">
-            <a:schemeClr val="accent1"/>
-          </a:lnRef>
-          <a:fillRef idx="3">
-            <a:schemeClr val="accent1"/>
-          </a:fillRef>
-          <a:effectRef idx="2">
-            <a:schemeClr val="accent1"/>
-          </a:effectRef>
-          <a:fontRef idx="minor">
-            <a:schemeClr val="lt1"/>
-          </a:fontRef>
-        </p:style>
-        <p:txBody>
-          <a:bodyPr rtlCol="0" anchor="ctr"/>
-          <a:lstStyle/>
-          <a:p>
-            <a:pPr algn="ctr"/>
-          </a:p>
-        </p:txBody>
-      </p:sp>
-      <p:sp>
-        <p:nvSpPr>
-          <p:cNvPr id="56" name="TextBox 55"/>
-          <p:cNvSpPr txBox="1"/>
-          <p:nvPr/>
-        </p:nvSpPr>
-        <p:spPr>
-          <a:xfrm>
-            <a:off x="8759952" y="3447288"/>
-            <a:ext cx="347472" cy="274320"/>
-          </a:xfrm>
-          <a:prstGeom prst="rect">
-            <a:avLst/>
-          </a:prstGeom>
-          <a:noFill/>
-        </p:spPr>
-        <p:txBody>
-          <a:bodyPr wrap="none">
-            <a:spAutoFit/>
-          </a:bodyPr>
-          <a:lstStyle/>
-          <a:p>
-            <a:pPr algn="l"/>
-            <a:r>
-              <a:rPr sz="900" b="1" i="0">
-                <a:solidFill>
-                  <a:srgbClr val="AAAAAA"/>
-                </a:solidFill>
-              </a:rPr>
-              <a:t>#3</a:t>
-            </a:r>
-          </a:p>
-        </p:txBody>
-      </p:sp>
-      <p:sp>
-        <p:nvSpPr>
-          <p:cNvPr id="57" name="TextBox 56"/>
-          <p:cNvSpPr txBox="1"/>
-          <p:nvPr/>
-        </p:nvSpPr>
-        <p:spPr>
-          <a:xfrm>
-            <a:off x="9125712" y="3447288"/>
-            <a:ext cx="1097280" cy="274320"/>
-          </a:xfrm>
-          <a:prstGeom prst="rect">
-            <a:avLst/>
-          </a:prstGeom>
-          <a:noFill/>
-        </p:spPr>
-        <p:txBody>
-          <a:bodyPr wrap="none">
-            <a:spAutoFit/>
-          </a:bodyPr>
-          <a:lstStyle/>
-          <a:p>
-            <a:pPr algn="l"/>
-            <a:r>
-              <a:rPr sz="900" b="1" i="0">
-                <a:solidFill>
-                  <a:srgbClr val="F0F0F0"/>
-                </a:solidFill>
-              </a:rPr>
-              <a:t>✈ United</a:t>
-            </a:r>
-          </a:p>
-        </p:txBody>
-      </p:sp>
-      <p:sp>
-        <p:nvSpPr>
-          <p:cNvPr id="58" name="Rectangle 57"/>
-          <p:cNvSpPr/>
-          <p:nvPr/>
-        </p:nvSpPr>
-        <p:spPr>
-          <a:xfrm>
-            <a:off x="9125712" y="3794760"/>
-            <a:ext cx="530352" cy="237744"/>
-          </a:xfrm>
-          <a:prstGeom prst="rect">
-            <a:avLst/>
-          </a:prstGeom>
-          <a:solidFill>
-            <a:srgbClr val="555555"/>
-          </a:solidFill>
-          <a:ln>
-            <a:noFill/>
-          </a:ln>
-        </p:spPr>
-        <p:style>
-          <a:lnRef idx="1">
-            <a:schemeClr val="accent1"/>
-          </a:lnRef>
-          <a:fillRef idx="3">
-            <a:schemeClr val="accent1"/>
-          </a:fillRef>
-          <a:effectRef idx="2">
-            <a:schemeClr val="accent1"/>
-          </a:effectRef>
-          <a:fontRef idx="minor">
-            <a:schemeClr val="lt1"/>
-          </a:fontRef>
-        </p:style>
-        <p:txBody>
-          <a:bodyPr rtlCol="0" anchor="ctr"/>
-          <a:lstStyle/>
-          <a:p>
-            <a:pPr algn="ctr"/>
-          </a:p>
-        </p:txBody>
-      </p:sp>
-      <p:sp>
-        <p:nvSpPr>
-          <p:cNvPr id="59" name="TextBox 58"/>
-          <p:cNvSpPr txBox="1"/>
-          <p:nvPr/>
-        </p:nvSpPr>
-        <p:spPr>
-          <a:xfrm>
-            <a:off x="9125712" y="3794760"/>
-            <a:ext cx="530352" cy="237744"/>
-          </a:xfrm>
-          <a:prstGeom prst="rect">
-            <a:avLst/>
-          </a:prstGeom>
-          <a:noFill/>
-        </p:spPr>
-        <p:txBody>
-          <a:bodyPr wrap="none">
-            <a:spAutoFit/>
-          </a:bodyPr>
-          <a:lstStyle/>
-          <a:p>
-            <a:pPr algn="ctr"/>
-            <a:r>
-              <a:rPr sz="800" b="1" i="0">
-                <a:solidFill>
-                  <a:srgbClr val="FFFFFF"/>
-                </a:solidFill>
-              </a:rPr>
-              <a:t>68.9</a:t>
-            </a:r>
-          </a:p>
-        </p:txBody>
-      </p:sp>
-      <p:sp>
-        <p:nvSpPr>
-          <p:cNvPr id="60" name="TextBox 59"/>
-          <p:cNvSpPr txBox="1"/>
-          <p:nvPr/>
-        </p:nvSpPr>
-        <p:spPr>
-          <a:xfrm>
-            <a:off x="9710928" y="3447288"/>
-            <a:ext cx="548640" cy="274320"/>
-          </a:xfrm>
-          <a:prstGeom prst="rect">
-            <a:avLst/>
-          </a:prstGeom>
-          <a:noFill/>
-        </p:spPr>
-        <p:txBody>
-          <a:bodyPr wrap="none">
-            <a:spAutoFit/>
-          </a:bodyPr>
-          <a:lstStyle/>
-          <a:p>
-            <a:pPr algn="l"/>
-            <a:r>
-              <a:rPr sz="900" b="0" i="0">
-                <a:solidFill>
-                  <a:srgbClr val="F0F0F0"/>
-                </a:solidFill>
-              </a:rPr>
-              <a:t>$278</a:t>
-            </a:r>
-          </a:p>
-        </p:txBody>
-      </p:sp>
-      <p:sp>
-        <p:nvSpPr>
-          <p:cNvPr id="61" name="Rectangle 60"/>
-          <p:cNvSpPr/>
-          <p:nvPr/>
-        </p:nvSpPr>
-        <p:spPr>
-          <a:xfrm>
-            <a:off x="11109960" y="3447288"/>
-            <a:ext cx="566928" cy="237744"/>
-          </a:xfrm>
-          <a:prstGeom prst="rect">
-            <a:avLst/>
-          </a:prstGeom>
-          <a:solidFill>
-            <a:srgbClr val="C0392B"/>
-          </a:solidFill>
-          <a:ln>
-            <a:noFill/>
-          </a:ln>
-        </p:spPr>
-        <p:style>
-          <a:lnRef idx="1">
-            <a:schemeClr val="accent1"/>
-          </a:lnRef>
-          <a:fillRef idx="3">
-            <a:schemeClr val="accent1"/>
-          </a:fillRef>
-          <a:effectRef idx="2">
-            <a:schemeClr val="accent1"/>
-          </a:effectRef>
-          <a:fontRef idx="minor">
-            <a:schemeClr val="lt1"/>
-          </a:fontRef>
-        </p:style>
-        <p:txBody>
-          <a:bodyPr rtlCol="0" anchor="ctr"/>
-          <a:lstStyle/>
-          <a:p>
-            <a:pPr algn="ctr"/>
-          </a:p>
-        </p:txBody>
-      </p:sp>
-      <p:sp>
-        <p:nvSpPr>
-          <p:cNvPr id="62" name="TextBox 61"/>
-          <p:cNvSpPr txBox="1"/>
-          <p:nvPr/>
-        </p:nvSpPr>
-        <p:spPr>
-          <a:xfrm>
-            <a:off x="11109960" y="3447288"/>
-            <a:ext cx="566928" cy="237744"/>
-          </a:xfrm>
-          <a:prstGeom prst="rect">
-            <a:avLst/>
-          </a:prstGeom>
-          <a:noFill/>
-        </p:spPr>
-        <p:txBody>
-          <a:bodyPr wrap="none">
-            <a:spAutoFit/>
-          </a:bodyPr>
-          <a:lstStyle/>
-          <a:p>
-            <a:pPr algn="ctr"/>
-            <a:r>
-              <a:rPr sz="800" b="1" i="0">
-                <a:solidFill>
-                  <a:srgbClr val="FFFFFF"/>
-                </a:solidFill>
-              </a:rPr>
-              <a:t>Book</a:t>
-            </a:r>
-          </a:p>
-        </p:txBody>
-      </p:sp>
-      <p:sp>
-        <p:nvSpPr>
-          <p:cNvPr id="63" name="Rectangle 62"/>
-          <p:cNvSpPr/>
-          <p:nvPr/>
-        </p:nvSpPr>
-        <p:spPr>
-          <a:xfrm>
-            <a:off x="8686800" y="4325112"/>
-            <a:ext cx="3108960" cy="822960"/>
-          </a:xfrm>
-          <a:prstGeom prst="rect">
-            <a:avLst/>
-          </a:prstGeom>
-          <a:solidFill>
-            <a:srgbClr val="222222"/>
-          </a:solidFill>
-          <a:ln>
-            <a:noFill/>
-          </a:ln>
-        </p:spPr>
-        <p:style>
-          <a:lnRef idx="1">
-            <a:schemeClr val="accent1"/>
-          </a:lnRef>
-          <a:fillRef idx="3">
-            <a:schemeClr val="accent1"/>
-          </a:fillRef>
-          <a:effectRef idx="2">
-            <a:schemeClr val="accent1"/>
-          </a:effectRef>
-          <a:fontRef idx="minor">
-            <a:schemeClr val="lt1"/>
-          </a:fontRef>
-        </p:style>
-        <p:txBody>
-          <a:bodyPr rtlCol="0" anchor="ctr"/>
-          <a:lstStyle/>
-          <a:p>
-            <a:pPr algn="ctr"/>
-          </a:p>
-        </p:txBody>
-      </p:sp>
-      <p:sp>
-        <p:nvSpPr>
-          <p:cNvPr id="64" name="TextBox 63"/>
-          <p:cNvSpPr txBox="1"/>
-          <p:nvPr/>
-        </p:nvSpPr>
-        <p:spPr>
-          <a:xfrm>
-            <a:off x="8759952" y="4379976"/>
-            <a:ext cx="347472" cy="274320"/>
-          </a:xfrm>
-          <a:prstGeom prst="rect">
-            <a:avLst/>
-          </a:prstGeom>
-          <a:noFill/>
-        </p:spPr>
-        <p:txBody>
-          <a:bodyPr wrap="none">
-            <a:spAutoFit/>
-          </a:bodyPr>
-          <a:lstStyle/>
-          <a:p>
-            <a:pPr algn="l"/>
-            <a:r>
-              <a:rPr sz="900" b="1" i="0">
-                <a:solidFill>
-                  <a:srgbClr val="AAAAAA"/>
-                </a:solidFill>
-              </a:rPr>
-              <a:t>#4</a:t>
-            </a:r>
-          </a:p>
-        </p:txBody>
-      </p:sp>
-      <p:sp>
-        <p:nvSpPr>
-          <p:cNvPr id="65" name="TextBox 64"/>
-          <p:cNvSpPr txBox="1"/>
-          <p:nvPr/>
-        </p:nvSpPr>
-        <p:spPr>
-          <a:xfrm>
-            <a:off x="9125712" y="4379976"/>
-            <a:ext cx="1097280" cy="274320"/>
-          </a:xfrm>
-          <a:prstGeom prst="rect">
-            <a:avLst/>
-          </a:prstGeom>
-          <a:noFill/>
-        </p:spPr>
-        <p:txBody>
-          <a:bodyPr wrap="none">
-            <a:spAutoFit/>
-          </a:bodyPr>
-          <a:lstStyle/>
-          <a:p>
-            <a:pPr algn="l"/>
-            <a:r>
-              <a:rPr sz="900" b="1" i="0">
-                <a:solidFill>
-                  <a:srgbClr val="F0F0F0"/>
-                </a:solidFill>
-              </a:rPr>
-              <a:t>✈ American</a:t>
-            </a:r>
-          </a:p>
-        </p:txBody>
-      </p:sp>
-      <p:sp>
-        <p:nvSpPr>
-          <p:cNvPr id="66" name="Rectangle 65"/>
-          <p:cNvSpPr/>
-          <p:nvPr/>
-        </p:nvSpPr>
-        <p:spPr>
-          <a:xfrm>
-            <a:off x="9125712" y="4727448"/>
-            <a:ext cx="530352" cy="237744"/>
-          </a:xfrm>
-          <a:prstGeom prst="rect">
-            <a:avLst/>
-          </a:prstGeom>
-          <a:solidFill>
-            <a:srgbClr val="555555"/>
-          </a:solidFill>
-          <a:ln>
-            <a:noFill/>
-          </a:ln>
-        </p:spPr>
-        <p:style>
-          <a:lnRef idx="1">
-            <a:schemeClr val="accent1"/>
-          </a:lnRef>
-          <a:fillRef idx="3">
-            <a:schemeClr val="accent1"/>
-          </a:fillRef>
-          <a:effectRef idx="2">
-            <a:schemeClr val="accent1"/>
-          </a:effectRef>
-          <a:fontRef idx="minor">
-            <a:schemeClr val="lt1"/>
-          </a:fontRef>
-        </p:style>
-        <p:txBody>
-          <a:bodyPr rtlCol="0" anchor="ctr"/>
-          <a:lstStyle/>
-          <a:p>
-            <a:pPr algn="ctr"/>
-          </a:p>
-        </p:txBody>
-      </p:sp>
-      <p:sp>
-        <p:nvSpPr>
-          <p:cNvPr id="67" name="TextBox 66"/>
-          <p:cNvSpPr txBox="1"/>
-          <p:nvPr/>
-        </p:nvSpPr>
-        <p:spPr>
-          <a:xfrm>
-            <a:off x="9125712" y="4727448"/>
-            <a:ext cx="530352" cy="237744"/>
-          </a:xfrm>
-          <a:prstGeom prst="rect">
-            <a:avLst/>
-          </a:prstGeom>
-          <a:noFill/>
-        </p:spPr>
-        <p:txBody>
-          <a:bodyPr wrap="none">
-            <a:spAutoFit/>
-          </a:bodyPr>
-          <a:lstStyle/>
-          <a:p>
-            <a:pPr algn="ctr"/>
-            <a:r>
-              <a:rPr sz="800" b="1" i="0">
-                <a:solidFill>
-                  <a:srgbClr val="FFFFFF"/>
-                </a:solidFill>
-              </a:rPr>
-              <a:t>61.2</a:t>
-            </a:r>
-          </a:p>
-        </p:txBody>
-      </p:sp>
-      <p:sp>
-        <p:nvSpPr>
-          <p:cNvPr id="68" name="TextBox 67"/>
-          <p:cNvSpPr txBox="1"/>
-          <p:nvPr/>
-        </p:nvSpPr>
-        <p:spPr>
-          <a:xfrm>
-            <a:off x="9710928" y="4379976"/>
-            <a:ext cx="548640" cy="274320"/>
-          </a:xfrm>
-          <a:prstGeom prst="rect">
-            <a:avLst/>
-          </a:prstGeom>
-          <a:noFill/>
-        </p:spPr>
-        <p:txBody>
-          <a:bodyPr wrap="none">
-            <a:spAutoFit/>
-          </a:bodyPr>
-          <a:lstStyle/>
-          <a:p>
-            <a:pPr algn="l"/>
-            <a:r>
-              <a:rPr sz="900" b="0" i="0">
-                <a:solidFill>
-                  <a:srgbClr val="F0F0F0"/>
-                </a:solidFill>
-              </a:rPr>
-              <a:t>$241</a:t>
-            </a:r>
-          </a:p>
-        </p:txBody>
-      </p:sp>
-      <p:sp>
-        <p:nvSpPr>
-          <p:cNvPr id="69" name="Rectangle 68"/>
-          <p:cNvSpPr/>
-          <p:nvPr/>
-        </p:nvSpPr>
-        <p:spPr>
-          <a:xfrm>
-            <a:off x="11109960" y="4379976"/>
-            <a:ext cx="566928" cy="237744"/>
-          </a:xfrm>
-          <a:prstGeom prst="rect">
-            <a:avLst/>
-          </a:prstGeom>
-          <a:solidFill>
-            <a:srgbClr val="C0392B"/>
-          </a:solidFill>
-          <a:ln>
-            <a:noFill/>
-          </a:ln>
-        </p:spPr>
-        <p:style>
-          <a:lnRef idx="1">
-            <a:schemeClr val="accent1"/>
-          </a:lnRef>
-          <a:fillRef idx="3">
-            <a:schemeClr val="accent1"/>
-          </a:fillRef>
-          <a:effectRef idx="2">
-            <a:schemeClr val="accent1"/>
-          </a:effectRef>
-          <a:fontRef idx="minor">
-            <a:schemeClr val="lt1"/>
-          </a:fontRef>
-        </p:style>
-        <p:txBody>
-          <a:bodyPr rtlCol="0" anchor="ctr"/>
-          <a:lstStyle/>
-          <a:p>
-            <a:pPr algn="ctr"/>
-          </a:p>
-        </p:txBody>
-      </p:sp>
-      <p:sp>
-        <p:nvSpPr>
-          <p:cNvPr id="70" name="TextBox 69"/>
-          <p:cNvSpPr txBox="1"/>
-          <p:nvPr/>
-        </p:nvSpPr>
-        <p:spPr>
-          <a:xfrm>
-            <a:off x="11109960" y="4379976"/>
-            <a:ext cx="566928" cy="237744"/>
-          </a:xfrm>
-          <a:prstGeom prst="rect">
-            <a:avLst/>
-          </a:prstGeom>
-          <a:noFill/>
-        </p:spPr>
-        <p:txBody>
-          <a:bodyPr wrap="none">
-            <a:spAutoFit/>
-          </a:bodyPr>
-          <a:lstStyle/>
-          <a:p>
-            <a:pPr algn="ctr"/>
-            <a:r>
-              <a:rPr sz="800" b="1" i="0">
-                <a:solidFill>
-                  <a:srgbClr val="FFFFFF"/>
-                </a:solidFill>
-              </a:rPr>
-              <a:t>Book</a:t>
-            </a:r>
-          </a:p>
-        </p:txBody>
-      </p:sp>
-      <p:sp>
-        <p:nvSpPr>
-          <p:cNvPr id="71" name="Rectangle 70"/>
-          <p:cNvSpPr/>
-          <p:nvPr/>
-        </p:nvSpPr>
-        <p:spPr>
-          <a:xfrm>
-            <a:off x="8686800" y="5257800"/>
-            <a:ext cx="3108960" cy="822960"/>
-          </a:xfrm>
-          <a:prstGeom prst="rect">
-            <a:avLst/>
-          </a:prstGeom>
-          <a:solidFill>
-            <a:srgbClr val="222222"/>
-          </a:solidFill>
-          <a:ln>
-            <a:noFill/>
-          </a:ln>
-        </p:spPr>
-        <p:style>
-          <a:lnRef idx="1">
-            <a:schemeClr val="accent1"/>
-          </a:lnRef>
-          <a:fillRef idx="3">
-            <a:schemeClr val="accent1"/>
-          </a:fillRef>
-          <a:effectRef idx="2">
-            <a:schemeClr val="accent1"/>
-          </a:effectRef>
-          <a:fontRef idx="minor">
-            <a:schemeClr val="lt1"/>
-          </a:fontRef>
-        </p:style>
-        <p:txBody>
-          <a:bodyPr rtlCol="0" anchor="ctr"/>
-          <a:lstStyle/>
-          <a:p>
-            <a:pPr algn="ctr"/>
-          </a:p>
-        </p:txBody>
-      </p:sp>
-      <p:sp>
-        <p:nvSpPr>
-          <p:cNvPr id="72" name="TextBox 71"/>
-          <p:cNvSpPr txBox="1"/>
-          <p:nvPr/>
-        </p:nvSpPr>
-        <p:spPr>
-          <a:xfrm>
-            <a:off x="8759952" y="5312664"/>
-            <a:ext cx="347472" cy="274320"/>
-          </a:xfrm>
-          <a:prstGeom prst="rect">
-            <a:avLst/>
-          </a:prstGeom>
-          <a:noFill/>
-        </p:spPr>
-        <p:txBody>
-          <a:bodyPr wrap="none">
-            <a:spAutoFit/>
-          </a:bodyPr>
-          <a:lstStyle/>
-          <a:p>
-            <a:pPr algn="l"/>
-            <a:r>
-              <a:rPr sz="900" b="1" i="0">
-                <a:solidFill>
-                  <a:srgbClr val="AAAAAA"/>
-                </a:solidFill>
-              </a:rPr>
-              <a:t>#5</a:t>
-            </a:r>
-          </a:p>
-        </p:txBody>
-      </p:sp>
-      <p:sp>
-        <p:nvSpPr>
-          <p:cNvPr id="73" name="TextBox 72"/>
-          <p:cNvSpPr txBox="1"/>
-          <p:nvPr/>
-        </p:nvSpPr>
-        <p:spPr>
-          <a:xfrm>
-            <a:off x="9125712" y="5312664"/>
-            <a:ext cx="1097280" cy="274320"/>
-          </a:xfrm>
-          <a:prstGeom prst="rect">
-            <a:avLst/>
-          </a:prstGeom>
-          <a:noFill/>
-        </p:spPr>
-        <p:txBody>
-          <a:bodyPr wrap="none">
-            <a:spAutoFit/>
-          </a:bodyPr>
-          <a:lstStyle/>
-          <a:p>
-            <a:pPr algn="l"/>
-            <a:r>
-              <a:rPr sz="900" b="1" i="0">
-                <a:solidFill>
-                  <a:srgbClr val="F0F0F0"/>
-                </a:solidFill>
-              </a:rPr>
-              <a:t>✈ Spirit</a:t>
-            </a:r>
-          </a:p>
-        </p:txBody>
-      </p:sp>
-      <p:sp>
-        <p:nvSpPr>
-          <p:cNvPr id="74" name="Rectangle 73"/>
-          <p:cNvSpPr/>
-          <p:nvPr/>
-        </p:nvSpPr>
-        <p:spPr>
-          <a:xfrm>
-            <a:off x="9125712" y="5660136"/>
-            <a:ext cx="530352" cy="237744"/>
-          </a:xfrm>
-          <a:prstGeom prst="rect">
-            <a:avLst/>
-          </a:prstGeom>
-          <a:solidFill>
-            <a:srgbClr val="555555"/>
-          </a:solidFill>
-          <a:ln>
-            <a:noFill/>
-          </a:ln>
-        </p:spPr>
-        <p:style>
-          <a:lnRef idx="1">
-            <a:schemeClr val="accent1"/>
-          </a:lnRef>
-          <a:fillRef idx="3">
-            <a:schemeClr val="accent1"/>
-          </a:fillRef>
-          <a:effectRef idx="2">
-            <a:schemeClr val="accent1"/>
-          </a:effectRef>
-          <a:fontRef idx="minor">
-            <a:schemeClr val="lt1"/>
-          </a:fontRef>
-        </p:style>
-        <p:txBody>
-          <a:bodyPr rtlCol="0" anchor="ctr"/>
-          <a:lstStyle/>
-          <a:p>
-            <a:pPr algn="ctr"/>
-          </a:p>
-        </p:txBody>
-      </p:sp>
-      <p:sp>
-        <p:nvSpPr>
-          <p:cNvPr id="75" name="TextBox 74"/>
-          <p:cNvSpPr txBox="1"/>
-          <p:nvPr/>
-        </p:nvSpPr>
-        <p:spPr>
-          <a:xfrm>
-            <a:off x="9125712" y="5660136"/>
-            <a:ext cx="530352" cy="237744"/>
-          </a:xfrm>
-          <a:prstGeom prst="rect">
-            <a:avLst/>
-          </a:prstGeom>
-          <a:noFill/>
-        </p:spPr>
-        <p:txBody>
-          <a:bodyPr wrap="none">
-            <a:spAutoFit/>
-          </a:bodyPr>
-          <a:lstStyle/>
-          <a:p>
-            <a:pPr algn="ctr"/>
-            <a:r>
-              <a:rPr sz="800" b="1" i="0">
-                <a:solidFill>
-                  <a:srgbClr val="FFFFFF"/>
-                </a:solidFill>
-              </a:rPr>
-              <a:t>43.8</a:t>
-            </a:r>
-          </a:p>
-        </p:txBody>
-      </p:sp>
-      <p:sp>
-        <p:nvSpPr>
-          <p:cNvPr id="76" name="TextBox 75"/>
-          <p:cNvSpPr txBox="1"/>
-          <p:nvPr/>
-        </p:nvSpPr>
-        <p:spPr>
-          <a:xfrm>
-            <a:off x="9710928" y="5312664"/>
-            <a:ext cx="548640" cy="274320"/>
-          </a:xfrm>
-          <a:prstGeom prst="rect">
-            <a:avLst/>
-          </a:prstGeom>
-          <a:noFill/>
-        </p:spPr>
-        <p:txBody>
-          <a:bodyPr wrap="none">
-            <a:spAutoFit/>
-          </a:bodyPr>
-          <a:lstStyle/>
-          <a:p>
-            <a:pPr algn="l"/>
-            <a:r>
-              <a:rPr sz="900" b="0" i="0">
-                <a:solidFill>
-                  <a:srgbClr val="F0F0F0"/>
-                </a:solidFill>
-              </a:rPr>
-              <a:t>$94</a:t>
+              <a:t>SkyCompare helps travelers cut through the noise — not just finding the cheapest flight, but the right flight based on what matters most to them.</a:t>
             </a:r>
           </a:p>
         </p:txBody>

</xml_diff>

<commit_message>
Fix black results screenshot on slide, add GitHub URL
</commit_message>
<xml_diff>
--- a/SkyCompare_Slide.pptx
+++ b/SkyCompare_Slide.pptx
@@ -3355,13 +3355,47 @@
       </p:sp>
       <p:sp>
         <p:nvSpPr>
-          <p:cNvPr id="9" name="Rectangle 8"/>
+          <p:cNvPr id="9" name="TextBox 8"/>
+          <p:cNvSpPr txBox="1"/>
+          <p:nvPr/>
+        </p:nvSpPr>
+        <p:spPr>
+          <a:xfrm>
+            <a:off x="320040" y="2029968"/>
+            <a:ext cx="4297680" cy="228600"/>
+          </a:xfrm>
+          <a:prstGeom prst="rect">
+            <a:avLst/>
+          </a:prstGeom>
+          <a:noFill/>
+        </p:spPr>
+        <p:txBody>
+          <a:bodyPr wrap="none">
+            <a:spAutoFit/>
+          </a:bodyPr>
+          <a:lstStyle/>
+          <a:p>
+            <a:pPr algn="l"/>
+            <a:r>
+              <a:rPr sz="900" b="0" i="0">
+                <a:solidFill>
+                  <a:srgbClr val="C0392B"/>
+                </a:solidFill>
+              </a:rPr>
+              <a:t>github.com/ksu-is/SkyCompare</a:t>
+            </a:r>
+          </a:p>
+        </p:txBody>
+      </p:sp>
+      <p:sp>
+        <p:nvSpPr>
+          <p:cNvPr id="10" name="Rectangle 9"/>
           <p:cNvSpPr/>
           <p:nvPr/>
         </p:nvSpPr>
         <p:spPr>
           <a:xfrm>
-            <a:off x="320040" y="2176272"/>
+            <a:off x="320040" y="2304288"/>
             <a:ext cx="4023360" cy="27432"/>
           </a:xfrm>
           <a:prstGeom prst="rect">
@@ -3398,13 +3432,13 @@
       </p:sp>
       <p:sp>
         <p:nvSpPr>
-          <p:cNvPr id="10" name="TextBox 9"/>
+          <p:cNvPr id="11" name="TextBox 10"/>
           <p:cNvSpPr txBox="1"/>
           <p:nvPr/>
         </p:nvSpPr>
         <p:spPr>
           <a:xfrm>
-            <a:off x="320040" y="2304288"/>
+            <a:off x="320040" y="2432304"/>
             <a:ext cx="4160520" cy="3657600"/>
           </a:xfrm>
           <a:prstGeom prst="rect">
@@ -3559,7 +3593,7 @@
       </p:sp>
       <p:sp>
         <p:nvSpPr>
-          <p:cNvPr id="11" name="Rectangle 10"/>
+          <p:cNvPr id="12" name="Rectangle 11"/>
           <p:cNvSpPr/>
           <p:nvPr/>
         </p:nvSpPr>
@@ -3602,7 +3636,7 @@
       </p:sp>
       <p:sp>
         <p:nvSpPr>
-          <p:cNvPr id="12" name="Rectangle 11"/>
+          <p:cNvPr id="13" name="Rectangle 12"/>
           <p:cNvSpPr/>
           <p:nvPr/>
         </p:nvSpPr>
@@ -3647,7 +3681,7 @@
       </p:sp>
       <p:sp>
         <p:nvSpPr>
-          <p:cNvPr id="13" name="TextBox 12"/>
+          <p:cNvPr id="14" name="TextBox 13"/>
           <p:cNvSpPr txBox="1"/>
           <p:nvPr/>
         </p:nvSpPr>
@@ -3681,7 +3715,7 @@
       </p:sp>
       <p:sp>
         <p:nvSpPr>
-          <p:cNvPr id="14" name="Rectangle 13"/>
+          <p:cNvPr id="15" name="Rectangle 14"/>
           <p:cNvSpPr/>
           <p:nvPr/>
         </p:nvSpPr>
@@ -3726,7 +3760,7 @@
       </p:sp>
       <p:sp>
         <p:nvSpPr>
-          <p:cNvPr id="15" name="TextBox 14"/>
+          <p:cNvPr id="16" name="TextBox 15"/>
           <p:cNvSpPr txBox="1"/>
           <p:nvPr/>
         </p:nvSpPr>
@@ -3760,7 +3794,7 @@
       </p:sp>
       <p:pic>
         <p:nvPicPr>
-          <p:cNvPr id="16" name="Picture 15" descr="Skycompare2.png"/>
+          <p:cNvPr id="17" name="Picture 16" descr="Skycompare2.png"/>
           <p:cNvPicPr>
             <a:picLocks noChangeAspect="1"/>
           </p:cNvPicPr>
@@ -3784,7 +3818,7 @@
       </p:pic>
       <p:pic>
         <p:nvPicPr>
-          <p:cNvPr id="17" name="Picture 16" descr="Skycompare1.png"/>
+          <p:cNvPr id="18" name="Picture 17" descr="Skycompare1.png"/>
           <p:cNvPicPr>
             <a:picLocks noChangeAspect="1"/>
           </p:cNvPicPr>
@@ -3808,7 +3842,7 @@
       </p:pic>
       <p:sp>
         <p:nvSpPr>
-          <p:cNvPr id="18" name="Rectangle 17"/>
+          <p:cNvPr id="19" name="Rectangle 18"/>
           <p:cNvSpPr/>
           <p:nvPr/>
         </p:nvSpPr>
@@ -3851,7 +3885,7 @@
       </p:sp>
       <p:sp>
         <p:nvSpPr>
-          <p:cNvPr id="19" name="Rectangle 18"/>
+          <p:cNvPr id="20" name="Rectangle 19"/>
           <p:cNvSpPr/>
           <p:nvPr/>
         </p:nvSpPr>
@@ -3863,9 +3897,7 @@
           <a:prstGeom prst="rect">
             <a:avLst/>
           </a:prstGeom>
-          <a:solidFill>
-            <a:srgbClr val="000000"/>
-          </a:solidFill>
+          <a:noFill/>
           <a:ln>
             <a:solidFill>
               <a:srgbClr val="333333"/>
@@ -3896,7 +3928,7 @@
       </p:sp>
       <p:sp>
         <p:nvSpPr>
-          <p:cNvPr id="20" name="TextBox 19"/>
+          <p:cNvPr id="21" name="TextBox 20"/>
           <p:cNvSpPr txBox="1"/>
           <p:nvPr/>
         </p:nvSpPr>

</xml_diff>